<commit_message>
fix: update GitHub repository link in README and build script
</commit_message>
<xml_diff>
--- a/docs/GlucoTwin_presentation.pptx
+++ b/docs/GlucoTwin_presentation.pptx
@@ -2311,7 +2311,7 @@
       </p:sp>
       <p:pic>
         <p:nvPicPr>
-          <p:cNvPr id="4" name="Image 0" descr="03_ablation.png">    </p:cNvPr>
+          <p:cNvPr id="4" name="Image 0" descr="/home/claude/glucotwin-repo/scripts/../docs/figures/03_ablation.png">    </p:cNvPr>
           <p:cNvPicPr>
             <a:picLocks noChangeAspect="1"/>
           </p:cNvPicPr>
@@ -4383,7 +4383,7 @@
                 <a:ea typeface="Calibri" pitchFamily="34" charset="-122"/>
                 <a:cs typeface="Calibri" pitchFamily="34" charset="-120"/>
               </a:rPr>
-              <a:t>github.com/…/GlucoTwin</a:t>
+              <a:t>github.com/gyxcit/GlucoTwin</a:t>
             </a:r>
             <a:endParaRPr lang="en-US" sz="1100" dirty="0"/>
           </a:p>
@@ -10017,7 +10017,7 @@
       </p:sp>
       <p:pic>
         <p:nvPicPr>
-          <p:cNvPr id="4" name="Image 0" descr="02_horizons.png">    </p:cNvPr>
+          <p:cNvPr id="4" name="Image 0" descr="/home/claude/glucotwin-repo/scripts/../docs/figures/02_horizons.png">    </p:cNvPr>
           <p:cNvPicPr>
             <a:picLocks noChangeAspect="1"/>
           </p:cNvPicPr>
@@ -10688,7 +10688,7 @@
       </p:sp>
       <p:pic>
         <p:nvPicPr>
-          <p:cNvPr id="4" name="Image 0" descr="05_mae_vs_clinical.png">    </p:cNvPr>
+          <p:cNvPr id="4" name="Image 0" descr="/home/claude/glucotwin-repo/scripts/../docs/figures/05_mae_vs_clinical.png">    </p:cNvPr>
           <p:cNvPicPr>
             <a:picLocks noChangeAspect="1"/>
           </p:cNvPicPr>

</xml_diff>